<commit_message>
Slides v2: team review (Gary, Claudia) folded into the reproducible build
- RMSE ($37/wk) replaces the R² range; premiums shown as 2.7-5.4x RMSE
- signal vs noise ($31 vs $15), all-county 2019->2022 slope (0.90, 974), within-state ranks
- wording fixes: $100-$201, ">= 3 of 4" screen, "All 998 metro", "(712 counties)"
- missing factors: OEWS 39-9011 excludes preschool teachers (SOC 25-2011)
- all new statistics computed in final_analysis.py; Word document updated to match

Co-Authored-By: Claude Opus 5.5 <noreply@anthropic.com>
</commit_message>
<xml_diff>
--- a/Final_Project_Slides.pptx
+++ b/Final_Project_Slides.pptx
@@ -3205,7 +3205,7 @@
                 <a:ea typeface="Cambria" pitchFamily="34" charset="-122"/>
                 <a:cs typeface="Cambria" pitchFamily="34" charset="-120"/>
               </a:rPr>
-              <a:t>Ten counties charge $100–$200 a week above their cost prediction</a:t>
+              <a:t>Ten counties price $100–$201 a week above cost: 2.7–5.4× the model's typical error</a:t>
             </a:r>
             <a:endParaRPr lang="en-US" sz="2200" dirty="0"/>
           </a:p>
@@ -3864,7 +3864,7 @@
                 <a:ea typeface="Calibri" pitchFamily="34" charset="-122"/>
                 <a:cs typeface="Calibri" pitchFamily="34" charset="-120"/>
               </a:rPr>
-              <a:t>R² = 0.61, re-estimated every year</a:t>
+              <a:t>R² = 0.61, RMSE $37/week; refit every year</a:t>
             </a:r>
             <a:endParaRPr lang="en-US" sz="1000" dirty="0"/>
           </a:p>
@@ -4241,7 +4241,7 @@
                 <a:ea typeface="Calibri" pitchFamily="34" charset="-122"/>
                 <a:cs typeface="Calibri" pitchFamily="34" charset="-120"/>
               </a:rPr>
-              <a:t>≥ 5,000 children under 6 with working parents; premium &gt; 0 every year 2019–22</a:t>
+              <a:t>≥ 5,000 kids under 6, parents working; premium &gt; 0 in every observed year 2019–22 (≥ 3 of 4)</a:t>
             </a:r>
             <a:endParaRPr lang="en-US" sz="1100" dirty="0"/>
           </a:p>
@@ -4605,7 +4605,7 @@
                 <a:ea typeface="Calibri" pitchFamily="34" charset="-122"/>
                 <a:cs typeface="Calibri" pitchFamily="34" charset="-120"/>
               </a:rPr>
-              <a:t>2019 premium predicts 2022 premium (slope)</a:t>
+              <a:t>2019 premium predicts 2022 premium (slope, 712 counties)</a:t>
             </a:r>
             <a:endParaRPr lang="en-US" sz="1100" dirty="0"/>
           </a:p>
@@ -4722,7 +4722,7 @@
                 <a:ea typeface="Cambria" pitchFamily="34" charset="-122"/>
                 <a:cs typeface="Cambria" pitchFamily="34" charset="-120"/>
               </a:rPr>
-              <a:t>0.56–0.67</a:t>
+              <a:t>$37</a:t>
             </a:r>
             <a:endParaRPr lang="en-US" sz="2800" dirty="0"/>
           </a:p>
@@ -4761,7 +4761,7 @@
                 <a:ea typeface="Calibri" pitchFamily="34" charset="-122"/>
                 <a:cs typeface="Calibri" pitchFamily="34" charset="-120"/>
               </a:rPr>
-              <a:t>cost-model R² in every year 2015–22</a:t>
+              <a:t>typical miss (RMSE). What costs don't explain is the premium we rank on; top 10 clear it 2.7–5.4×</a:t>
             </a:r>
             <a:endParaRPr lang="en-US" sz="1100" dirty="0"/>
           </a:p>
@@ -4839,7 +4839,7 @@
                 <a:ea typeface="Calibri" pitchFamily="34" charset="-122"/>
                 <a:cs typeface="Calibri" pitchFamily="34" charset="-120"/>
               </a:rPr>
-              <a:t>of premium variation is between states (regional survey prices)</a:t>
+              <a:t>of premium variation is between states; a within-state model keeps all 4 high-confidence picks in its top 8</a:t>
             </a:r>
             <a:endParaRPr lang="en-US" sz="1100" dirty="0"/>
           </a:p>
@@ -5536,7 +5536,7 @@
                 <a:ea typeface="Cambria" pitchFamily="34" charset="-122"/>
                 <a:cs typeface="Cambria" pitchFamily="34" charset="-120"/>
               </a:rPr>
-              <a:t>Top 10 vs. all metro counties (2022)</a:t>
+              <a:t>Top 10 vs. all 998 metro counties (2022)</a:t>
             </a:r>
             <a:endParaRPr lang="en-US" sz="1300" dirty="0"/>
           </a:p>
@@ -5614,7 +5614,7 @@
                 <a:ea typeface="Calibri" pitchFamily="34" charset="-122"/>
                 <a:cs typeface="Calibri" pitchFamily="34" charset="-120"/>
               </a:rPr>
-              <a:t>All metro</a:t>
+              <a:t>All 998 metro</a:t>
             </a:r>
             <a:endParaRPr lang="en-US" sz="1000" dirty="0"/>
           </a:p>
@@ -6350,7 +6350,7 @@
                 <a:ea typeface="Cambria" pitchFamily="34" charset="-122"/>
                 <a:cs typeface="Cambria" pitchFamily="34" charset="-120"/>
               </a:rPr>
-              <a:t>Premiums persist: high-premium markets stay on top</a:t>
+              <a:t>Premiums persist, so they are signal, not noise</a:t>
             </a:r>
             <a:endParaRPr lang="en-US" sz="2200" dirty="0"/>
           </a:p>
@@ -6471,7 +6471,7 @@
                 <a:ea typeface="Calibri" pitchFamily="34" charset="-122"/>
                 <a:cs typeface="Calibri" pitchFamily="34" charset="-120"/>
               </a:rPr>
-              <a:t>A $1 premium in 2019 still meant about 88¢ in 2022, through the pandemic</a:t>
+              <a:t>A $1 premium in 2019 still meant about 88¢ in 2022 (712 counties; 0.90 across all 974)</a:t>
             </a:r>
             <a:endParaRPr lang="en-US" sz="1200" dirty="0"/>
           </a:p>
@@ -6486,11 +6486,11 @@
         <p:spPr>
           <a:xfrm>
             <a:off x="5897880" y="2560320"/>
-            <a:ext cx="2788920" cy="914400"/>
+            <a:ext cx="2788920" cy="1188720"/>
           </a:xfrm>
           <a:prstGeom prst="roundRect">
             <a:avLst>
-              <a:gd name="adj" fmla="val 8000"/>
+              <a:gd name="adj" fmla="val 6154"/>
             </a:avLst>
           </a:prstGeom>
           <a:solidFill>
@@ -6513,7 +6513,7 @@
         <p:spPr>
           <a:xfrm>
             <a:off x="6035040" y="2633472"/>
-            <a:ext cx="2560320" cy="777240"/>
+            <a:ext cx="2560320" cy="1051560"/>
           </a:xfrm>
           <a:prstGeom prst="rect">
             <a:avLst/>
@@ -6529,7 +6529,7 @@
               <a:buNone/>
             </a:pPr>
             <a:r>
-              <a:rPr lang="en-US" sz="1200" b="1" dirty="0">
+              <a:rPr lang="en-US" sz="1150" b="1" dirty="0">
                 <a:solidFill>
                   <a:srgbClr val="1B2A2F"/>
                 </a:solidFill>
@@ -6537,13 +6537,13 @@
                 <a:ea typeface="Calibri" pitchFamily="34" charset="-122"/>
                 <a:cs typeface="Calibri" pitchFamily="34" charset="-120"/>
               </a:rPr>
-              <a:t>All 10 picks </a:t>
-            </a:r>
-            <a:pPr indent="0" marL="0">
-              <a:buNone/>
-            </a:pPr>
-            <a:r>
-              <a:rPr lang="en-US" sz="1200" dirty="0">
+              <a:t>Signal, not noise: </a:t>
+            </a:r>
+            <a:pPr indent="0" marL="0">
+              <a:buNone/>
+            </a:pPr>
+            <a:r>
+              <a:rPr lang="en-US" sz="1150" dirty="0">
                 <a:solidFill>
                   <a:srgbClr val="1B2A2F"/>
                 </a:solidFill>
@@ -6551,9 +6551,9 @@
                 <a:ea typeface="Calibri" pitchFamily="34" charset="-122"/>
                 <a:cs typeface="Calibri" pitchFamily="34" charset="-120"/>
               </a:rPr>
-              <a:t>had a positive premium in every observed year since 2019; 8 were above $75/week already in 2019.</a:t>
-            </a:r>
-            <a:endParaRPr lang="en-US" sz="1200" dirty="0"/>
+              <a:t>the lasting part of each premium (SD $31/wk) is twice the yearly noise ($15). Knowing the 2019 premium cuts the 2022 price error from $37 to $22.</a:t>
+            </a:r>
+            <a:endParaRPr lang="en-US" sz="1150" dirty="0"/>
           </a:p>
         </p:txBody>
       </p:sp>
@@ -6565,8 +6565,8 @@
         </p:nvSpPr>
         <p:spPr>
           <a:xfrm>
-            <a:off x="5897880" y="3611880"/>
-            <a:ext cx="2788920" cy="1051560"/>
+            <a:off x="5897880" y="3858768"/>
+            <a:ext cx="2788920" cy="868680"/>
           </a:xfrm>
           <a:prstGeom prst="rect">
             <a:avLst/>
@@ -6582,7 +6582,7 @@
               <a:buNone/>
             </a:pPr>
             <a:r>
-              <a:rPr lang="en-US" sz="1050" i="1" dirty="0">
+              <a:rPr lang="en-US" sz="1000" i="1" dirty="0">
                 <a:solidFill>
                   <a:srgbClr val="4F5D62"/>
                 </a:solidFill>
@@ -6592,7 +6592,7 @@
               </a:rPr>
               <a:t>Caveat: states survey prices every 2–3 years and NDCP interpolates in between, so adjacent years look more alike than they are. The 3+ year comparisons are the honest test, and they hold.</a:t>
             </a:r>
-            <a:endParaRPr lang="en-US" sz="1050" dirty="0"/>
+            <a:endParaRPr lang="en-US" sz="1000" dirty="0"/>
           </a:p>
         </p:txBody>
       </p:sp>
@@ -6833,7 +6833,7 @@
                 <a:ea typeface="Calibri" pitchFamily="34" charset="-122"/>
                 <a:cs typeface="Calibri" pitchFamily="34" charset="-120"/>
               </a:rPr>
-              <a:t>Regulation: </a:t>
+              <a:t>Labor cost: </a:t>
             </a:r>
             <a:pPr indent="0" marL="0">
               <a:buNone/>
@@ -6847,7 +6847,7 @@
                 <a:ea typeface="Calibri" pitchFamily="34" charset="-122"/>
                 <a:cs typeface="Calibri" pitchFamily="34" charset="-120"/>
               </a:rPr>
-              <a:t>Staff-to-child ratios raise cost per child beyond wages (MN is among the strictest)</a:t>
+              <a:t>OEWS childcare workers exclude preschool teachers (SOC 25‑2011); ratio rules raise cost per child (MN strictest)</a:t>
             </a:r>
             <a:endParaRPr lang="en-US" sz="1200" dirty="0"/>
           </a:p>

</xml_diff>

<commit_message>
Final deck: timed speaker script, one-line titles, presenter guide
- speaker notes rewritten as a 9:30 timed script (say / numbers / hand-off / likely Q)
- slide 2 title fits one line
- make_presenter_guide.py builds Presenter_Guide (run of show, script, Q&A cheat sheet)

Co-Authored-By: Claude Opus 5.5 <noreply@anthropic.com>
</commit_message>
<xml_diff>
--- a/Final_Project_Slides.pptx
+++ b/Final_Project_Slides.pptx
@@ -1424,7 +1424,11 @@
           <a:p>
             <a:r>
               <a:rPr lang="en-US" dirty="0"/>
-              <a:t>We were asked where a for-profit chain should open center-based preschools. Our definition of attractive: prices high relative to the two main costs, childcare wages and rent. Our answer: four counties pass every check (Arlington, Alexandria, San Francisco, Norfolk); six more look promising but need local price validation. We analyzed all metro counties with 2022 data; the slides walk through the list, how we got it, the market profile, whether premiums last, and what the data miss.</a:t>
+              <a:t>SLIDE 1 | 1:15 min | Speaker A
+SAY: We were asked where a for-profit chain should open center-based preschools. We call a market attractive when families pay much more than the two main costs, childcare wages and rent, would predict.
+Our answer: start with four counties, Arlington, VA, Alexandria, VA, San Francisco, CA, Norfolk, MA. In each, the median preschool price is $116 to $201 a week above what local labor and rent costs predict. Six more counties look promising but need a local price check.
+We looked at all 998 metro counties with 2022 data; 155 passed our market-size and persistence screens.
+HAND-OFF: Here is the full top 10.</a:t>
             </a:r>
             <a:endParaRPr lang="en-US" dirty="0"/>
           </a:p>
@@ -1512,7 +1516,14 @@
           <a:p>
             <a:r>
               <a:rPr lang="en-US" dirty="0"/>
-              <a:t>Premium = actual 2022 median preschool price minus the price our cost model predicts from childcare wages and rent. Arlington charges about $496 a week where costs predict $296. Coral bars pass every data check. Amber bars are real premiums in the data but rest on weaker price data: four report a regional survey rate, two have price trends far outside the norm that the NDCP interpolates between surveys. If those six fail local validation, the alternates on the right (Howard MD, Burlington NJ, DuPage IL, Gloucester NJ) pass every check.</a:t>
+              <a:t>SLIDE 2 | 2:00 min | Speaker A
+SAY: Each bar is a county's premium: its actual 2022 preschool price minus the price our cost model predicts.
+Example: Arlington charges about $496 a week where wages and rent predict $296, a premium of $201.
+Our model's typical miss is $37 a week, so these premiums are 2.7 to 5.4 times bigger than normal noise.
+Coral bars pass every data check. Amber bars are real in the data but rest on weaker price data: four use one regional survey price shared by many counties, and two show price jumps faster than 99% of counties (+77% and +59%, 2018-22).
+If the amber six fail a local check, the alternates on the right pass every check.
+HAND-OFF: How did we get these numbers? [Speaker B]
+LIKELY Q: Why not just pick the most expensive counties? A: Expensive places also cost more to run; we want price HIGH RELATIVE TO COST.</a:t>
             </a:r>
             <a:endParaRPr lang="en-US" dirty="0"/>
           </a:p>
@@ -1600,7 +1611,11 @@
           <a:p>
             <a:r>
               <a:rPr lang="en-US" dirty="0"/>
-              <a:t>Step 1: across metro counties we regress the median preschool price on childcare-worker wages and rent; both matter separately and together explain about 60% of price differences. Step 2: the residual is the premium. Step 3: we keep markets with at least 5,000 young children whose parents all work, and premiums that were positive in every observed year since 2019. Step 4: rank, then flag counties whose price data are weaker. Reliability: premiums predict themselves three years ahead, a log model gives the same ranking, and the model fits every year. The caveat in amber: a big share of premiums is state-level, partly because several states publish regional survey prices.</a:t>
+              <a:t>SLIDE 3 | 2:00 min | Speaker B
+SAY: Four steps. (1) Across metro counties we regress the preschool price on childcare-worker wages and rent. Each $1,000 of annual wages adds $7.09 a week; each $100 of monthly rent adds $5.91. (2) The premium is the gap between actual and predicted price. (3) We keep markets with at least 5,000 young children whose parents all work, and premiums that were positive in every year we observe since 2019. (4) We rank and flag weaker price data.
+RELIABILITY (bottom row): the 2019 premium predicts the 2022 premium (slope 0.88); a log-price model gives the same ranking (0.98); the typical miss is $37. Caveat in amber: 43% of premium differences are between states, partly because some states publish regional prices. But even comparing counties only within their own state, our four high-confidence picks stay in the top 8.
+HAND-OFF: What do these markets look like? [Speaker C]
+LIKELY Q: R² of 0.61 is low? A: The unexplained part IS the premium we rank on; a perfect fit would leave nothing to find.</a:t>
             </a:r>
             <a:endParaRPr lang="en-US" dirty="0"/>
           </a:p>
@@ -1688,7 +1703,11 @@
           <a:p>
             <a:r>
               <a:rPr lang="en-US" dirty="0"/>
-              <a:t>We pick locations on four measured characteristics: the premium, the two cost drivers that define it, and demand depth. The recommended counties share a profile: about 50% higher income, far more college-educated women, more women working full-time. Income, female college share and the share of young children needing care are each significantly related to premiums, but together explain only 7% of them, so most of the premium is local market conditions our data do not see directly. That is why we rank on the premium itself.</a:t>
+              <a:t>SLIDE 4 | 1:30 min | Speaker C
+SAY: We pick locations on four measured characteristics: the premium, the two costs that define it, and demand depth.
+Our top 10 are affluent and dual-earner: per-capita income about $56k vs $38k, and 49% of women hold a bachelor's degree vs 31%.
+Important nuance: demographics alone explain only 7% of premiums. So we rank on the measured premium, and use demographics only as a sanity check.
+HAND-OFF: Will these premiums last?</a:t>
             </a:r>
             <a:endParaRPr lang="en-US" dirty="0"/>
           </a:p>
@@ -1776,7 +1795,12 @@
           <a:p>
             <a:r>
               <a:rPr lang="en-US" dirty="0"/>
-              <a:t>We re-estimated the cost model every year and tracked each county's premium. Premiums fade slowly: correlation with 2022 is 0.94 one year back, 0.82 three years back, 0.58 seven years back. Of today's top-decile counties, 69% were already top decile in 2019. A regression of 2022 on 2019 premiums has slope 0.88. Caveat: survey cycles and NDCP's interpolation make adjacent years artificially similar, so we lean on the 2019 vs 2022 comparison.</a:t>
+              <a:t>SLIDE 5 | 1:30 min | Speaker C
+SAY: Yes. We rebuilt the cost model every year. A dollar of premium in 2019 was still worth about 88 cents in 2022, right through the pandemic.
+The lines show the link fading slowly: of today's top-10% counties, 69% were already top 10% in 2019.
+The lasting part of a premium (about $31 a week) is twice the year-to-year noise ($15). Premiums are a market feature, not luck.
+Caveat: states survey prices every 2-3 years and the database fills in between, so neighbouring years look more alike than they are; we therefore lean on the 2019 vs 2022 comparison.
+HAND-OFF: What would we still check before investing? [Speaker D]</a:t>
             </a:r>
             <a:endParaRPr lang="en-US" dirty="0"/>
           </a:p>
@@ -1864,7 +1888,10 @@
           <a:p>
             <a:r>
               <a:rPr lang="en-US" dirty="0"/>
-              <a:t>Our model sees prices and two costs, not supply. A high premium could signal unmet demand or a market that is hard to enter. State ratio rules raise labor cost per child; residential rent is only a proxy for commercial leases; six states have no usable 2022 prices; and NDCP prices are posted survey medians. Next steps: diligence on the four high-confidence counties, local price checks for the six to verify, and adding capacity and commercial rents. Data handling decisions are documented in the appendix document and the GitHub repository.</a:t>
+              <a:t>SLIDE 6 | 1:15 min | Speaker D (then lead Q&amp;A)
+SAY: Our model sees prices and two costs, not supply. Five gaps matter: competition and licensed capacity; labor cost (our wage data cover childcare workers, not preschool teachers, and ratio rules differ by state); commercial rents rather than residential; six states with no 2022 prices, including Philadelphia and St. Louis; and survey-based posted prices.
+NEXT STEPS: site and competitor scan in Arlington, VA, Alexandria, VA, San Francisco, CA, Norfolk, MA; collect local prices for the six amber counties; add capacity and commercial rents; rerun when newer data arrive.
+CLOSE: Four counties are ready for diligence today; six more after a local price check. Data-handling details are in our appendix and GitHub repository.</a:t>
             </a:r>
             <a:endParaRPr lang="en-US" dirty="0"/>
           </a:p>
@@ -3205,7 +3232,7 @@
                 <a:ea typeface="Cambria" pitchFamily="34" charset="-122"/>
                 <a:cs typeface="Cambria" pitchFamily="34" charset="-120"/>
               </a:rPr>
-              <a:t>Ten counties price $100–$201 a week above cost: 2.7–5.4× the model's typical error</a:t>
+              <a:t>Top 10 charge $100–$201/wk above cost: 2.7–5.4× typical error</a:t>
             </a:r>
             <a:endParaRPr lang="en-US" sz="2200" dirty="0"/>
           </a:p>

</xml_diff>